<commit_message>
Use the real Grafana dashboard screenshot on the observability slide
</commit_message>
<xml_diff>
--- a/demo/ClinicDesk-Capstone.pptx
+++ b/demo/ClinicDesk-Capstone.pptx
@@ -3626,511 +3626,45 @@
           </a:p>
         </p:txBody>
       </p:sp>
-      <p:sp>
-        <p:nvSpPr>
-          <p:cNvPr id="8" name="Rounded Rectangle 7"/>
-          <p:cNvSpPr/>
-          <p:nvPr/>
-        </p:nvSpPr>
-        <p:spPr>
-          <a:xfrm>
-            <a:off x="6583680" y="1737360"/>
-            <a:ext cx="1645920" cy="914400"/>
-          </a:xfrm>
-          <a:prstGeom prst="roundRect">
-            <a:avLst>
-              <a:gd name="adj" fmla="val 12000"/>
-            </a:avLst>
-          </a:prstGeom>
-          <a:solidFill>
-            <a:srgbClr val="FEF3C7"/>
-          </a:solidFill>
+      <p:pic>
+        <p:nvPicPr>
+          <p:cNvPr id="8" name="Picture 7" descr="grafana-crop.png"/>
+          <p:cNvPicPr>
+            <a:picLocks noChangeAspect="1"/>
+          </p:cNvPicPr>
+          <p:nvPr/>
+        </p:nvPicPr>
+        <p:blipFill>
+          <a:blip r:embed="rId2"/>
+          <a:stretch>
+            <a:fillRect/>
+          </a:stretch>
+        </p:blipFill>
+        <p:spPr>
+          <a:xfrm>
+            <a:off x="6309360" y="1645920"/>
+            <a:ext cx="5486400" cy="3451123"/>
+          </a:xfrm>
+          <a:prstGeom prst="rect">
+            <a:avLst/>
+          </a:prstGeom>
           <a:ln>
-            <a:noFill/>
+            <a:solidFill>
+              <a:srgbClr val="0F766E"/>
+            </a:solidFill>
           </a:ln>
-          <a:effectLst/>
-        </p:spPr>
-        <p:style>
-          <a:lnRef idx="1">
-            <a:schemeClr val="accent1"/>
-          </a:lnRef>
-          <a:fillRef idx="3">
-            <a:schemeClr val="accent1"/>
-          </a:fillRef>
-          <a:effectRef idx="2">
-            <a:schemeClr val="accent1"/>
-          </a:effectRef>
-          <a:fontRef idx="minor">
-            <a:schemeClr val="lt1"/>
-          </a:fontRef>
-        </p:style>
-        <p:txBody>
-          <a:bodyPr rtlCol="0" anchor="ctr" wrap="square" lIns="109728" rIns="109728"/>
-          <a:lstStyle/>
-          <a:p>
-            <a:pPr algn="ctr"/>
-            <a:r>
-              <a:rPr b="1" sz="1300">
-                <a:solidFill>
-                  <a:srgbClr val="0B3B3C"/>
-                </a:solidFill>
-                <a:latin typeface="Calibri"/>
-              </a:rPr>
-              <a:t>Requests / sec</a:t>
-            </a:r>
-          </a:p>
-        </p:txBody>
-      </p:sp>
-      <p:sp>
-        <p:nvSpPr>
-          <p:cNvPr id="9" name="Rounded Rectangle 8"/>
-          <p:cNvSpPr/>
-          <p:nvPr/>
-        </p:nvSpPr>
-        <p:spPr>
-          <a:xfrm>
-            <a:off x="8321040" y="1737360"/>
-            <a:ext cx="1645920" cy="914400"/>
-          </a:xfrm>
-          <a:prstGeom prst="roundRect">
-            <a:avLst>
-              <a:gd name="adj" fmla="val 12000"/>
-            </a:avLst>
-          </a:prstGeom>
-          <a:solidFill>
-            <a:srgbClr val="FEF3C7"/>
-          </a:solidFill>
-          <a:ln>
-            <a:noFill/>
-          </a:ln>
-          <a:effectLst/>
-        </p:spPr>
-        <p:style>
-          <a:lnRef idx="1">
-            <a:schemeClr val="accent1"/>
-          </a:lnRef>
-          <a:fillRef idx="3">
-            <a:schemeClr val="accent1"/>
-          </a:fillRef>
-          <a:effectRef idx="2">
-            <a:schemeClr val="accent1"/>
-          </a:effectRef>
-          <a:fontRef idx="minor">
-            <a:schemeClr val="lt1"/>
-          </a:fontRef>
-        </p:style>
-        <p:txBody>
-          <a:bodyPr rtlCol="0" anchor="ctr" wrap="square" lIns="109728" rIns="109728"/>
-          <a:lstStyle/>
-          <a:p>
-            <a:pPr algn="ctr"/>
-            <a:r>
-              <a:rPr b="1" sz="1300">
-                <a:solidFill>
-                  <a:srgbClr val="0B3B3C"/>
-                </a:solidFill>
-                <a:latin typeface="Calibri"/>
-              </a:rPr>
-              <a:t>5xx error ratio</a:t>
-            </a:r>
-          </a:p>
-        </p:txBody>
-      </p:sp>
-      <p:sp>
-        <p:nvSpPr>
-          <p:cNvPr id="10" name="Rounded Rectangle 9"/>
-          <p:cNvSpPr/>
-          <p:nvPr/>
-        </p:nvSpPr>
-        <p:spPr>
-          <a:xfrm>
-            <a:off x="10058400" y="1737360"/>
-            <a:ext cx="1645920" cy="914400"/>
-          </a:xfrm>
-          <a:prstGeom prst="roundRect">
-            <a:avLst>
-              <a:gd name="adj" fmla="val 12000"/>
-            </a:avLst>
-          </a:prstGeom>
-          <a:solidFill>
-            <a:srgbClr val="FEF3C7"/>
-          </a:solidFill>
-          <a:ln>
-            <a:noFill/>
-          </a:ln>
-          <a:effectLst/>
-        </p:spPr>
-        <p:style>
-          <a:lnRef idx="1">
-            <a:schemeClr val="accent1"/>
-          </a:lnRef>
-          <a:fillRef idx="3">
-            <a:schemeClr val="accent1"/>
-          </a:fillRef>
-          <a:effectRef idx="2">
-            <a:schemeClr val="accent1"/>
-          </a:effectRef>
-          <a:fontRef idx="minor">
-            <a:schemeClr val="lt1"/>
-          </a:fontRef>
-        </p:style>
-        <p:txBody>
-          <a:bodyPr rtlCol="0" anchor="ctr" wrap="square" lIns="109728" rIns="109728"/>
-          <a:lstStyle/>
-          <a:p>
-            <a:pPr algn="ctr"/>
-            <a:r>
-              <a:rPr b="1" sz="1300">
-                <a:solidFill>
-                  <a:srgbClr val="0B3B3C"/>
-                </a:solidFill>
-                <a:latin typeface="Calibri"/>
-              </a:rPr>
-              <a:t>p95 latency</a:t>
-            </a:r>
-          </a:p>
-        </p:txBody>
-      </p:sp>
-      <p:sp>
-        <p:nvSpPr>
-          <p:cNvPr id="11" name="Rounded Rectangle 10"/>
-          <p:cNvSpPr/>
-          <p:nvPr/>
-        </p:nvSpPr>
-        <p:spPr>
-          <a:xfrm>
-            <a:off x="6583680" y="2788920"/>
-            <a:ext cx="1645920" cy="914400"/>
-          </a:xfrm>
-          <a:prstGeom prst="roundRect">
-            <a:avLst>
-              <a:gd name="adj" fmla="val 12000"/>
-            </a:avLst>
-          </a:prstGeom>
-          <a:solidFill>
-            <a:srgbClr val="FEF3C7"/>
-          </a:solidFill>
-          <a:ln>
-            <a:noFill/>
-          </a:ln>
-          <a:effectLst/>
-        </p:spPr>
-        <p:style>
-          <a:lnRef idx="1">
-            <a:schemeClr val="accent1"/>
-          </a:lnRef>
-          <a:fillRef idx="3">
-            <a:schemeClr val="accent1"/>
-          </a:fillRef>
-          <a:effectRef idx="2">
-            <a:schemeClr val="accent1"/>
-          </a:effectRef>
-          <a:fontRef idx="minor">
-            <a:schemeClr val="lt1"/>
-          </a:fontRef>
-        </p:style>
-        <p:txBody>
-          <a:bodyPr rtlCol="0" anchor="ctr" wrap="square" lIns="109728" rIns="109728"/>
-          <a:lstStyle/>
-          <a:p>
-            <a:pPr algn="ctr"/>
-            <a:r>
-              <a:rPr b="1" sz="1300">
-                <a:solidFill>
-                  <a:srgbClr val="0B3B3C"/>
-                </a:solidFill>
-                <a:latin typeface="Calibri"/>
-              </a:rPr>
-              <a:t>Bookings (1h)</a:t>
-            </a:r>
-          </a:p>
-        </p:txBody>
-      </p:sp>
-      <p:sp>
-        <p:nvSpPr>
-          <p:cNvPr id="12" name="Rounded Rectangle 11"/>
-          <p:cNvSpPr/>
-          <p:nvPr/>
-        </p:nvSpPr>
-        <p:spPr>
-          <a:xfrm>
-            <a:off x="8321040" y="2788920"/>
-            <a:ext cx="1645920" cy="914400"/>
-          </a:xfrm>
-          <a:prstGeom prst="roundRect">
-            <a:avLst>
-              <a:gd name="adj" fmla="val 12000"/>
-            </a:avLst>
-          </a:prstGeom>
-          <a:solidFill>
-            <a:srgbClr val="FEF3C7"/>
-          </a:solidFill>
-          <a:ln>
-            <a:noFill/>
-          </a:ln>
-          <a:effectLst/>
-        </p:spPr>
-        <p:style>
-          <a:lnRef idx="1">
-            <a:schemeClr val="accent1"/>
-          </a:lnRef>
-          <a:fillRef idx="3">
-            <a:schemeClr val="accent1"/>
-          </a:fillRef>
-          <a:effectRef idx="2">
-            <a:schemeClr val="accent1"/>
-          </a:effectRef>
-          <a:fontRef idx="minor">
-            <a:schemeClr val="lt1"/>
-          </a:fontRef>
-        </p:style>
-        <p:txBody>
-          <a:bodyPr rtlCol="0" anchor="ctr" wrap="square" lIns="109728" rIns="109728"/>
-          <a:lstStyle/>
-          <a:p>
-            <a:pPr algn="ctr"/>
-            <a:r>
-              <a:rPr b="1" sz="1300">
-                <a:solidFill>
-                  <a:srgbClr val="0B3B3C"/>
-                </a:solidFill>
-                <a:latin typeface="Calibri"/>
-              </a:rPr>
-              <a:t>Blocked double-bookings</a:t>
-            </a:r>
-          </a:p>
-        </p:txBody>
-      </p:sp>
-      <p:sp>
-        <p:nvSpPr>
-          <p:cNvPr id="13" name="Rounded Rectangle 12"/>
-          <p:cNvSpPr/>
-          <p:nvPr/>
-        </p:nvSpPr>
-        <p:spPr>
-          <a:xfrm>
-            <a:off x="10058400" y="2788920"/>
-            <a:ext cx="1645920" cy="914400"/>
-          </a:xfrm>
-          <a:prstGeom prst="roundRect">
-            <a:avLst>
-              <a:gd name="adj" fmla="val 12000"/>
-            </a:avLst>
-          </a:prstGeom>
-          <a:solidFill>
-            <a:srgbClr val="FEF3C7"/>
-          </a:solidFill>
-          <a:ln>
-            <a:noFill/>
-          </a:ln>
-          <a:effectLst/>
-        </p:spPr>
-        <p:style>
-          <a:lnRef idx="1">
-            <a:schemeClr val="accent1"/>
-          </a:lnRef>
-          <a:fillRef idx="3">
-            <a:schemeClr val="accent1"/>
-          </a:fillRef>
-          <a:effectRef idx="2">
-            <a:schemeClr val="accent1"/>
-          </a:effectRef>
-          <a:fontRef idx="minor">
-            <a:schemeClr val="lt1"/>
-          </a:fontRef>
-        </p:style>
-        <p:txBody>
-          <a:bodyPr rtlCol="0" anchor="ctr" wrap="square" lIns="109728" rIns="109728"/>
-          <a:lstStyle/>
-          <a:p>
-            <a:pPr algn="ctr"/>
-            <a:r>
-              <a:rPr b="1" sz="1300">
-                <a:solidFill>
-                  <a:srgbClr val="0B3B3C"/>
-                </a:solidFill>
-                <a:latin typeface="Calibri"/>
-              </a:rPr>
-              <a:t>Backend pods up</a:t>
-            </a:r>
-          </a:p>
-        </p:txBody>
-      </p:sp>
-      <p:sp>
-        <p:nvSpPr>
-          <p:cNvPr id="14" name="Rounded Rectangle 13"/>
-          <p:cNvSpPr/>
-          <p:nvPr/>
-        </p:nvSpPr>
-        <p:spPr>
-          <a:xfrm>
-            <a:off x="6583680" y="3840479"/>
-            <a:ext cx="1645920" cy="914400"/>
-          </a:xfrm>
-          <a:prstGeom prst="roundRect">
-            <a:avLst>
-              <a:gd name="adj" fmla="val 12000"/>
-            </a:avLst>
-          </a:prstGeom>
-          <a:solidFill>
-            <a:srgbClr val="FEF3C7"/>
-          </a:solidFill>
-          <a:ln>
-            <a:noFill/>
-          </a:ln>
-          <a:effectLst/>
-        </p:spPr>
-        <p:style>
-          <a:lnRef idx="1">
-            <a:schemeClr val="accent1"/>
-          </a:lnRef>
-          <a:fillRef idx="3">
-            <a:schemeClr val="accent1"/>
-          </a:fillRef>
-          <a:effectRef idx="2">
-            <a:schemeClr val="accent1"/>
-          </a:effectRef>
-          <a:fontRef idx="minor">
-            <a:schemeClr val="lt1"/>
-          </a:fontRef>
-        </p:style>
-        <p:txBody>
-          <a:bodyPr rtlCol="0" anchor="ctr" wrap="square" lIns="109728" rIns="109728"/>
-          <a:lstStyle/>
-          <a:p>
-            <a:pPr algn="ctr"/>
-            <a:r>
-              <a:rPr b="1" sz="1300">
-                <a:solidFill>
-                  <a:srgbClr val="0B3B3C"/>
-                </a:solidFill>
-                <a:latin typeface="Calibri"/>
-              </a:rPr>
-              <a:t>Rate per endpoint</a:t>
-            </a:r>
-          </a:p>
-        </p:txBody>
-      </p:sp>
-      <p:sp>
-        <p:nvSpPr>
-          <p:cNvPr id="15" name="Rounded Rectangle 14"/>
-          <p:cNvSpPr/>
-          <p:nvPr/>
-        </p:nvSpPr>
-        <p:spPr>
-          <a:xfrm>
-            <a:off x="8321040" y="3840479"/>
-            <a:ext cx="1645920" cy="914400"/>
-          </a:xfrm>
-          <a:prstGeom prst="roundRect">
-            <a:avLst>
-              <a:gd name="adj" fmla="val 12000"/>
-            </a:avLst>
-          </a:prstGeom>
-          <a:solidFill>
-            <a:srgbClr val="FEF3C7"/>
-          </a:solidFill>
-          <a:ln>
-            <a:noFill/>
-          </a:ln>
-          <a:effectLst/>
-        </p:spPr>
-        <p:style>
-          <a:lnRef idx="1">
-            <a:schemeClr val="accent1"/>
-          </a:lnRef>
-          <a:fillRef idx="3">
-            <a:schemeClr val="accent1"/>
-          </a:fillRef>
-          <a:effectRef idx="2">
-            <a:schemeClr val="accent1"/>
-          </a:effectRef>
-          <a:fontRef idx="minor">
-            <a:schemeClr val="lt1"/>
-          </a:fontRef>
-        </p:style>
-        <p:txBody>
-          <a:bodyPr rtlCol="0" anchor="ctr" wrap="square" lIns="109728" rIns="109728"/>
-          <a:lstStyle/>
-          <a:p>
-            <a:pPr algn="ctr"/>
-            <a:r>
-              <a:rPr b="1" sz="1300">
-                <a:solidFill>
-                  <a:srgbClr val="0B3B3C"/>
-                </a:solidFill>
-                <a:latin typeface="Calibri"/>
-              </a:rPr>
-              <a:t>p50 / p95 per endpoint</a:t>
-            </a:r>
-          </a:p>
-        </p:txBody>
-      </p:sp>
-      <p:sp>
-        <p:nvSpPr>
-          <p:cNvPr id="16" name="Rounded Rectangle 15"/>
-          <p:cNvSpPr/>
-          <p:nvPr/>
-        </p:nvSpPr>
-        <p:spPr>
-          <a:xfrm>
-            <a:off x="10058400" y="3840479"/>
-            <a:ext cx="1645920" cy="914400"/>
-          </a:xfrm>
-          <a:prstGeom prst="roundRect">
-            <a:avLst>
-              <a:gd name="adj" fmla="val 12000"/>
-            </a:avLst>
-          </a:prstGeom>
-          <a:solidFill>
-            <a:srgbClr val="FEF3C7"/>
-          </a:solidFill>
-          <a:ln>
-            <a:noFill/>
-          </a:ln>
-          <a:effectLst/>
-        </p:spPr>
-        <p:style>
-          <a:lnRef idx="1">
-            <a:schemeClr val="accent1"/>
-          </a:lnRef>
-          <a:fillRef idx="3">
-            <a:schemeClr val="accent1"/>
-          </a:fillRef>
-          <a:effectRef idx="2">
-            <a:schemeClr val="accent1"/>
-          </a:effectRef>
-          <a:fontRef idx="minor">
-            <a:schemeClr val="lt1"/>
-          </a:fontRef>
-        </p:style>
-        <p:txBody>
-          <a:bodyPr rtlCol="0" anchor="ctr" wrap="square" lIns="109728" rIns="109728"/>
-          <a:lstStyle/>
-          <a:p>
-            <a:pPr algn="ctr"/>
-            <a:r>
-              <a:rPr b="1" sz="1300">
-                <a:solidFill>
-                  <a:srgbClr val="0B3B3C"/>
-                </a:solidFill>
-                <a:latin typeface="Calibri"/>
-              </a:rPr>
-              <a:t>CPU + memory per pod</a:t>
-            </a:r>
-          </a:p>
-        </p:txBody>
-      </p:sp>
-      <p:sp>
-        <p:nvSpPr>
-          <p:cNvPr id="17" name="TextBox 16"/>
+        </p:spPr>
+      </p:pic>
+      <p:sp>
+        <p:nvSpPr>
+          <p:cNvPr id="9" name="TextBox 8"/>
           <p:cNvSpPr txBox="1"/>
           <p:nvPr/>
         </p:nvSpPr>
         <p:spPr>
           <a:xfrm>
-            <a:off x="6583680" y="5029200"/>
-            <a:ext cx="5120640" cy="731520"/>
+            <a:off x="6309360" y="5166360"/>
+            <a:ext cx="5486400" cy="548640"/>
           </a:xfrm>
           <a:prstGeom prst="rect">
             <a:avLst/>
@@ -4145,13 +3679,13 @@
           <a:p>
             <a:pPr algn="l"/>
             <a:r>
-              <a:rPr sz="1400" b="0">
+              <a:rPr sz="1200" b="0">
                 <a:solidFill>
                   <a:srgbClr val="64748B"/>
                 </a:solidFill>
                 <a:latin typeface="Calibri"/>
               </a:rPr>
-              <a:t>TODO: swap in a real Grafana screenshot here</a:t>
+              <a:t>Grafana on minikube while scripts/load-test.sh was running</a:t>
             </a:r>
           </a:p>
         </p:txBody>

</xml_diff>